<commit_message>
Restructure project to src/tests layout
Move source files to src/ and test files to tests/ for standard
Python project layout. Update all import paths, .env resolution,
log_samples references, and documentation accordingly.

Co-Authored-By: Claude Opus 4.6 <noreply@anthropic.com>
</commit_message>
<xml_diff>
--- a/DevOps_Incident_Suite_Presentation.pptx
+++ b/DevOps_Incident_Suite_Presentation.pptx
@@ -7375,7 +7375,7 @@
               </a:defRPr>
             </a:pPr>
             <a:r>
-              <a:t>app.py</a:t>
+              <a:t>src/app.py</a:t>
             </a:r>
           </a:p>
         </p:txBody>
@@ -7490,7 +7490,7 @@
               </a:defRPr>
             </a:pPr>
             <a:r>
-              <a:t>state.py</a:t>
+              <a:t>src/state.py</a:t>
             </a:r>
           </a:p>
         </p:txBody>
@@ -7605,7 +7605,7 @@
               </a:defRPr>
             </a:pPr>
             <a:r>
-              <a:t>agents.py</a:t>
+              <a:t>src/agents.py</a:t>
             </a:r>
           </a:p>
         </p:txBody>
@@ -7720,7 +7720,7 @@
               </a:defRPr>
             </a:pPr>
             <a:r>
-              <a:t>graph.py</a:t>
+              <a:t>src/graph.py</a:t>
             </a:r>
           </a:p>
         </p:txBody>
@@ -7835,7 +7835,7 @@
               </a:defRPr>
             </a:pPr>
             <a:r>
-              <a:t>tools.py</a:t>
+              <a:t>src/tools.py</a:t>
             </a:r>
           </a:p>
         </p:txBody>
@@ -7950,7 +7950,7 @@
               </a:defRPr>
             </a:pPr>
             <a:r>
-              <a:t>watcher.py</a:t>
+              <a:t>src/watcher.py</a:t>
             </a:r>
           </a:p>
         </p:txBody>
@@ -8065,7 +8065,7 @@
               </a:defRPr>
             </a:pPr>
             <a:r>
-              <a:t>log_samples/</a:t>
+              <a:t>src/log_samples/</a:t>
             </a:r>
           </a:p>
         </p:txBody>
@@ -8180,7 +8180,7 @@
               </a:defRPr>
             </a:pPr>
             <a:r>
-              <a:t>test_*.py</a:t>
+              <a:t>tests/test_*.py</a:t>
             </a:r>
           </a:p>
         </p:txBody>

</xml_diff>